<commit_message>
Entrega final ACT03: modelo RVT, presentacion completa, guion 2 min y video base
Co-Authored-By: Claude Opus 5.5 <noreply@anthropic.com>
Claude-Session: https://claude.ai/code/session_013BqHCBCBMxPVbrFpj9LrZE
</commit_message>
<xml_diff>
--- a/ENTREGA_ACT03_ARROYO/3_SUSTENTACION/PARAM_2026-2_ACT03_ARROYO_PRESENTACION.pptx
+++ b/ENTREGA_ACT03_ARROYO/3_SUSTENTACION/PARAM_2026-2_ACT03_ARROYO_PRESENTACION.pptx
@@ -114,34 +114,34 @@
   <p:extLst>
     <p:ext uri="{521415D9-36F7-43E2-AB2F-B90AF26B5E84}">
       <p14:sectionLst xmlns:p14="http://schemas.microsoft.com/office/powerpoint/2010/main">
-        <p14:section name="Inicio" id="{8ea21efd-240d-a6f4-a631-e94f0122aeb5}">
+        <p14:section name="Inicio" id="{4d005d6b-938d-6443-43f5-de77b5234b9e}">
           <p14:sldIdLst>
             <p14:sldId id="256"/>
           </p14:sldIdLst>
         </p14:section>
-        <p14:section name="Paciente y objetos" id="{6c44fb80-14b8-1b65-3921-2b4e9df8a7b0}">
+        <p14:section name="Paciente y objetos" id="{2cae3043-7ef3-7a3e-9330-53445329d65a}">
           <p14:sldIdLst>
             <p14:sldId id="257"/>
           </p14:sldIdLst>
         </p14:section>
-        <p14:section name="Criterios" id="{10c2dc7e-244e-00e4-367d-fe29daaa62d9}">
+        <p14:section name="Criterios" id="{93bebd96-76e0-59ea-4f1d-7d09f6f47cf3}">
           <p14:sldIdLst>
             <p14:sldId id="258"/>
             <p14:sldId id="259"/>
           </p14:sldIdLst>
         </p14:section>
-        <p14:section name="Implementacion" id="{e664cb84-67f7-072a-e790-888e4584f930}">
+        <p14:section name="Implementacion" id="{a8c95da1-607c-3295-1c91-709cded0341a}">
           <p14:sldIdLst>
             <p14:sldId id="260"/>
             <p14:sldId id="261"/>
           </p14:sldIdLst>
         </p14:section>
-        <p14:section name="Validacion" id="{9a069508-ea2e-63ba-af36-9f842b68e918}">
+        <p14:section name="Validacion" id="{1136a7bc-3ec9-817a-9a14-9d543799e8f9}">
           <p14:sldIdLst>
             <p14:sldId id="262"/>
           </p14:sldIdLst>
         </p14:section>
-        <p14:section name="Cierre" id="{3f32111f-41f8-392e-176e-a4615d098961}">
+        <p14:section name="Cierre" id="{b317b2a8-5966-cee8-5cdf-059709d1817d}">
           <p14:sldIdLst>
             <p14:sldId id="263"/>
           </p14:sldIdLst>
@@ -5933,41 +5933,65 @@
       </p:sp>
       <p:sp>
         <p:nvSpPr>
-          <p:cNvPr id="5" name="imagen"/>
+          <p:cNvPr id="5" name="marco"/>
           <p:cNvSpPr/>
           <p:nvPr/>
         </p:nvSpPr>
         <p:spPr>
           <a:xfrm>
-            <a:off x="548640" y="1417320"/>
-            <a:ext cx="3566160" cy="4023360"/>
+            <a:off x="548640" y="1325880"/>
+            <a:ext cx="2743200" cy="4526280"/>
           </a:xfrm>
           <a:prstGeom prst="roundRect">
             <a:avLst>
-              <a:gd name="adj" fmla="val 3846"/>
+              <a:gd name="adj" fmla="val 5000"/>
             </a:avLst>
           </a:prstGeom>
           <a:solidFill>
-            <a:schemeClr val="bg2"/>
+            <a:srgbClr val="FFFFFF"/>
           </a:solidFill>
-          <a:ln w="15875">
+          <a:ln w="12700">
             <a:solidFill>
-              <a:schemeClr val="tx2"/>
+              <a:srgbClr val="D5DBDF"/>
             </a:solidFill>
-            <a:prstDash val="dash"/>
+            <a:prstDash val="solid"/>
           </a:ln>
         </p:spPr>
       </p:sp>
-      <p:sp>
-        <p:nvSpPr>
-          <p:cNvPr id="6" name="Text 4"/>
+      <p:pic>
+        <p:nvPicPr>
+          <p:cNvPr id="6" name="Image 0" descr="Captura de Revit – columna C-30x30">    </p:cNvPr>
+          <p:cNvPicPr>
+            <a:picLocks noChangeAspect="1"/>
+          </p:cNvPicPr>
+          <p:nvPr/>
+        </p:nvPicPr>
+        <p:blipFill>
+          <a:blip r:embed="rId1"/>
+          <a:stretch>
+            <a:fillRect/>
+          </a:stretch>
+        </p:blipFill>
+        <p:spPr>
+          <a:xfrm>
+            <a:off x="756133" y="1325880"/>
+            <a:ext cx="2328214" cy="4526280"/>
+          </a:xfrm>
+          <a:prstGeom prst="rect">
+            <a:avLst/>
+          </a:prstGeom>
+        </p:spPr>
+      </p:pic>
+      <p:sp>
+        <p:nvSpPr>
+          <p:cNvPr id="7" name="Text 4"/>
           <p:cNvSpPr txBox="1"/>
           <p:nvPr/>
         </p:nvSpPr>
         <p:spPr>
           <a:xfrm>
-            <a:off x="731520" y="1417320"/>
-            <a:ext cx="3200400" cy="4023360"/>
+            <a:off x="548640" y="5897880"/>
+            <a:ext cx="2743200" cy="320040"/>
           </a:xfrm>
           <a:prstGeom prst="rect">
             <a:avLst/>
@@ -5976,214 +6000,1198 @@
           <a:ln/>
         </p:spPr>
         <p:txBody>
-          <a:bodyPr wrap="square" rtlCol="0" anchor="ctr"/>
+          <a:bodyPr wrap="square" lIns="0" tIns="0" rIns="0" bIns="0" rtlCol="0" anchor="ctr"/>
           <a:lstStyle/>
           <a:p>
             <a:pPr algn="ctr" indent="0" marL="0">
               <a:buNone/>
             </a:pPr>
             <a:r>
-              <a:rPr lang="en-US" sz="1300" b="1" dirty="0">
+              <a:rPr lang="en-US" sz="1100" i="1" dirty="0">
                 <a:solidFill>
                   <a:schemeClr val="tx2"/>
                 </a:solidFill>
               </a:rPr>
-              <a:t>INSERTE AQUÍ SU IMAGEN</a:t>
+              <a:t>Captura de Revit – columna C-30x30</a:t>
             </a:r>
-            <a:endParaRPr lang="en-US" sz="1300" dirty="0"/>
-          </a:p>
-          <a:p>
-            <a:pPr algn="ctr" indent="0" marL="0">
+            <a:endParaRPr lang="en-US" sz="1100" dirty="0"/>
+          </a:p>
+        </p:txBody>
+      </p:sp>
+      <p:graphicFrame>
+        <p:nvGraphicFramePr>
+          <p:cNvPr id="7" name="Table 0"/>
+          <p:cNvGraphicFramePr>
+            <a:graphicFrameLocks noGrp="1"/>
+          </p:cNvGraphicFramePr>
+          <p:nvPr>
+            <p:extLst>
+              <p:ext uri="{D42A27DB-BD31-4B8C-83A1-F6EECF244321}">
+                <p14:modId xmlns:p14="http://schemas.microsoft.com/office/powerpoint/2010/main" val="1579011935"/>
+              </p:ext>
+            </p:extLst>
+          </p:nvPr>
+        </p:nvGraphicFramePr>
+        <p:xfrm>
+          <a:off x="3657600" y="1325880"/>
+          <a:ext cx="8001000" cy="914400"/>
+        </p:xfrm>
+        <a:graphic>
+          <a:graphicData uri="http://schemas.openxmlformats.org/drawingml/2006/table">
+            <a:tbl>
+              <a:tblPr/>
+              <a:tblGrid>
+                <a:gridCol w="2377440"/>
+                <a:gridCol w="3611880"/>
+                <a:gridCol w="2011680"/>
+              </a:tblGrid>
+              <a:tr h="0">
+                <a:tc>
+                  <a:txBody>
+                    <a:bodyPr/>
+                    <a:lstStyle/>
+                    <a:p>
+                      <a:pPr indent="0" marL="0">
+                        <a:buNone/>
+                      </a:pPr>
+                      <a:r>
+                        <a:rPr lang="en-US" sz="1300" b="1" dirty="0">
+                          <a:solidFill>
+                            <a:schemeClr val="bg1"/>
+                          </a:solidFill>
+                        </a:rPr>
+                        <a:t>Dónde está</a:t>
+                      </a:r>
+                      <a:endParaRPr lang="en-US" sz="1300" dirty="0"/>
+                    </a:p>
+                  </a:txBody>
+                  <a:tcPr marL="91440" marR="91440" marT="45720" marB="45720">
+                    <a:lnL w="6350" cap="flat" cmpd="sng" algn="ctr">
+                      <a:solidFill>
+                        <a:srgbClr val="C9D1D6"/>
+                      </a:solidFill>
+                      <a:prstDash val="solid"/>
+                      <a:round/>
+                      <a:headEnd type="none" w="med" len="med"/>
+                      <a:tailEnd type="none" w="med" len="med"/>
+                    </a:lnL>
+                    <a:lnR w="6350" cap="flat" cmpd="sng" algn="ctr">
+                      <a:solidFill>
+                        <a:srgbClr val="C9D1D6"/>
+                      </a:solidFill>
+                      <a:prstDash val="solid"/>
+                      <a:round/>
+                      <a:headEnd type="none" w="med" len="med"/>
+                      <a:tailEnd type="none" w="med" len="med"/>
+                    </a:lnR>
+                    <a:lnT w="6350" cap="flat" cmpd="sng" algn="ctr">
+                      <a:solidFill>
+                        <a:srgbClr val="C9D1D6"/>
+                      </a:solidFill>
+                      <a:prstDash val="solid"/>
+                      <a:round/>
+                      <a:headEnd type="none" w="med" len="med"/>
+                      <a:tailEnd type="none" w="med" len="med"/>
+                    </a:lnT>
+                    <a:lnB w="6350" cap="flat" cmpd="sng" algn="ctr">
+                      <a:solidFill>
+                        <a:srgbClr val="C9D1D6"/>
+                      </a:solidFill>
+                      <a:prstDash val="solid"/>
+                      <a:round/>
+                      <a:headEnd type="none" w="med" len="med"/>
+                      <a:tailEnd type="none" w="med" len="med"/>
+                    </a:lnB>
+                    <a:solidFill>
+                      <a:schemeClr val="tx1"/>
+                    </a:solidFill>
+                  </a:tcPr>
+                </a:tc>
+                <a:tc>
+                  <a:txBody>
+                    <a:bodyPr/>
+                    <a:lstStyle/>
+                    <a:p>
+                      <a:pPr indent="0" marL="0">
+                        <a:buNone/>
+                      </a:pPr>
+                      <a:r>
+                        <a:rPr lang="en-US" sz="1300" b="1" dirty="0">
+                          <a:solidFill>
+                            <a:schemeClr val="bg1"/>
+                          </a:solidFill>
+                        </a:rPr>
+                        <a:t>Parámetros</a:t>
+                      </a:r>
+                      <a:endParaRPr lang="en-US" sz="1300" dirty="0"/>
+                    </a:p>
+                  </a:txBody>
+                  <a:tcPr marL="91440" marR="91440" marT="45720" marB="45720">
+                    <a:lnL w="6350" cap="flat" cmpd="sng" algn="ctr">
+                      <a:solidFill>
+                        <a:srgbClr val="C9D1D6"/>
+                      </a:solidFill>
+                      <a:prstDash val="solid"/>
+                      <a:round/>
+                      <a:headEnd type="none" w="med" len="med"/>
+                      <a:tailEnd type="none" w="med" len="med"/>
+                    </a:lnL>
+                    <a:lnR w="6350" cap="flat" cmpd="sng" algn="ctr">
+                      <a:solidFill>
+                        <a:srgbClr val="C9D1D6"/>
+                      </a:solidFill>
+                      <a:prstDash val="solid"/>
+                      <a:round/>
+                      <a:headEnd type="none" w="med" len="med"/>
+                      <a:tailEnd type="none" w="med" len="med"/>
+                    </a:lnR>
+                    <a:lnT w="6350" cap="flat" cmpd="sng" algn="ctr">
+                      <a:solidFill>
+                        <a:srgbClr val="C9D1D6"/>
+                      </a:solidFill>
+                      <a:prstDash val="solid"/>
+                      <a:round/>
+                      <a:headEnd type="none" w="med" len="med"/>
+                      <a:tailEnd type="none" w="med" len="med"/>
+                    </a:lnT>
+                    <a:lnB w="6350" cap="flat" cmpd="sng" algn="ctr">
+                      <a:solidFill>
+                        <a:srgbClr val="C9D1D6"/>
+                      </a:solidFill>
+                      <a:prstDash val="solid"/>
+                      <a:round/>
+                      <a:headEnd type="none" w="med" len="med"/>
+                      <a:tailEnd type="none" w="med" len="med"/>
+                    </a:lnB>
+                    <a:solidFill>
+                      <a:schemeClr val="tx1"/>
+                    </a:solidFill>
+                  </a:tcPr>
+                </a:tc>
+                <a:tc>
+                  <a:txBody>
+                    <a:bodyPr/>
+                    <a:lstStyle/>
+                    <a:p>
+                      <a:pPr indent="0" marL="0">
+                        <a:buNone/>
+                      </a:pPr>
+                      <a:r>
+                        <a:rPr lang="en-US" sz="1300" b="1" dirty="0">
+                          <a:solidFill>
+                            <a:schemeClr val="bg1"/>
+                          </a:solidFill>
+                        </a:rPr>
+                        <a:t>Clase</a:t>
+                      </a:r>
+                      <a:endParaRPr lang="en-US" sz="1300" dirty="0"/>
+                    </a:p>
+                  </a:txBody>
+                  <a:tcPr marL="91440" marR="91440" marT="45720" marB="45720">
+                    <a:lnL w="6350" cap="flat" cmpd="sng" algn="ctr">
+                      <a:solidFill>
+                        <a:srgbClr val="C9D1D6"/>
+                      </a:solidFill>
+                      <a:prstDash val="solid"/>
+                      <a:round/>
+                      <a:headEnd type="none" w="med" len="med"/>
+                      <a:tailEnd type="none" w="med" len="med"/>
+                    </a:lnL>
+                    <a:lnR w="6350" cap="flat" cmpd="sng" algn="ctr">
+                      <a:solidFill>
+                        <a:srgbClr val="C9D1D6"/>
+                      </a:solidFill>
+                      <a:prstDash val="solid"/>
+                      <a:round/>
+                      <a:headEnd type="none" w="med" len="med"/>
+                      <a:tailEnd type="none" w="med" len="med"/>
+                    </a:lnR>
+                    <a:lnT w="6350" cap="flat" cmpd="sng" algn="ctr">
+                      <a:solidFill>
+                        <a:srgbClr val="C9D1D6"/>
+                      </a:solidFill>
+                      <a:prstDash val="solid"/>
+                      <a:round/>
+                      <a:headEnd type="none" w="med" len="med"/>
+                      <a:tailEnd type="none" w="med" len="med"/>
+                    </a:lnT>
+                    <a:lnB w="6350" cap="flat" cmpd="sng" algn="ctr">
+                      <a:solidFill>
+                        <a:srgbClr val="C9D1D6"/>
+                      </a:solidFill>
+                      <a:prstDash val="solid"/>
+                      <a:round/>
+                      <a:headEnd type="none" w="med" len="med"/>
+                      <a:tailEnd type="none" w="med" len="med"/>
+                    </a:lnB>
+                    <a:solidFill>
+                      <a:schemeClr val="tx1"/>
+                    </a:solidFill>
+                  </a:tcPr>
+                </a:tc>
+              </a:tr>
+              <a:tr h="0">
+                <a:tc>
+                  <a:txBody>
+                    <a:bodyPr/>
+                    <a:lstStyle/>
+                    <a:p>
+                      <a:pPr indent="0" marL="0">
+                        <a:buNone/>
+                      </a:pPr>
+                      <a:r>
+                        <a:rPr lang="en-US" sz="1300" dirty="0">
+                          <a:solidFill>
+                            <a:schemeClr val="tx1"/>
+                          </a:solidFill>
+                        </a:rPr>
+                        <a:t>Gestionar → Parámetros de proyecto</a:t>
+                      </a:r>
+                      <a:endParaRPr lang="en-US" sz="1300" dirty="0"/>
+                    </a:p>
+                  </a:txBody>
+                  <a:tcPr marL="91440" marR="91440" marT="45720" marB="45720">
+                    <a:lnL w="6350" cap="flat" cmpd="sng" algn="ctr">
+                      <a:solidFill>
+                        <a:srgbClr val="C9D1D6"/>
+                      </a:solidFill>
+                      <a:prstDash val="solid"/>
+                      <a:round/>
+                      <a:headEnd type="none" w="med" len="med"/>
+                      <a:tailEnd type="none" w="med" len="med"/>
+                    </a:lnL>
+                    <a:lnR w="6350" cap="flat" cmpd="sng" algn="ctr">
+                      <a:solidFill>
+                        <a:srgbClr val="C9D1D6"/>
+                      </a:solidFill>
+                      <a:prstDash val="solid"/>
+                      <a:round/>
+                      <a:headEnd type="none" w="med" len="med"/>
+                      <a:tailEnd type="none" w="med" len="med"/>
+                    </a:lnR>
+                    <a:lnT w="6350" cap="flat" cmpd="sng" algn="ctr">
+                      <a:solidFill>
+                        <a:srgbClr val="C9D1D6"/>
+                      </a:solidFill>
+                      <a:prstDash val="solid"/>
+                      <a:round/>
+                      <a:headEnd type="none" w="med" len="med"/>
+                      <a:tailEnd type="none" w="med" len="med"/>
+                    </a:lnT>
+                    <a:lnB w="6350" cap="flat" cmpd="sng" algn="ctr">
+                      <a:solidFill>
+                        <a:srgbClr val="C9D1D6"/>
+                      </a:solidFill>
+                      <a:prstDash val="solid"/>
+                      <a:round/>
+                      <a:headEnd type="none" w="med" len="med"/>
+                      <a:tailEnd type="none" w="med" len="med"/>
+                    </a:lnB>
+                    <a:solidFill>
+                      <a:schemeClr val="bg2"/>
+                    </a:solidFill>
+                  </a:tcPr>
+                </a:tc>
+                <a:tc>
+                  <a:txBody>
+                    <a:bodyPr/>
+                    <a:lstStyle/>
+                    <a:p>
+                      <a:pPr indent="0" marL="0">
+                        <a:buNone/>
+                      </a:pPr>
+                      <a:r>
+                        <a:rPr lang="en-US" sz="1300" dirty="0">
+                          <a:solidFill>
+                            <a:schemeClr val="tx1"/>
+                          </a:solidFill>
+                        </a:rPr>
+                        <a:t>PAC_Codigo, PAC_Material, PAC_Resistencia, PAC_Nivel, PAC_Clasificacion</a:t>
+                      </a:r>
+                      <a:endParaRPr lang="en-US" sz="1300" dirty="0"/>
+                    </a:p>
+                  </a:txBody>
+                  <a:tcPr marL="91440" marR="91440" marT="45720" marB="45720">
+                    <a:lnL w="6350" cap="flat" cmpd="sng" algn="ctr">
+                      <a:solidFill>
+                        <a:srgbClr val="C9D1D6"/>
+                      </a:solidFill>
+                      <a:prstDash val="solid"/>
+                      <a:round/>
+                      <a:headEnd type="none" w="med" len="med"/>
+                      <a:tailEnd type="none" w="med" len="med"/>
+                    </a:lnL>
+                    <a:lnR w="6350" cap="flat" cmpd="sng" algn="ctr">
+                      <a:solidFill>
+                        <a:srgbClr val="C9D1D6"/>
+                      </a:solidFill>
+                      <a:prstDash val="solid"/>
+                      <a:round/>
+                      <a:headEnd type="none" w="med" len="med"/>
+                      <a:tailEnd type="none" w="med" len="med"/>
+                    </a:lnR>
+                    <a:lnT w="6350" cap="flat" cmpd="sng" algn="ctr">
+                      <a:solidFill>
+                        <a:srgbClr val="C9D1D6"/>
+                      </a:solidFill>
+                      <a:prstDash val="solid"/>
+                      <a:round/>
+                      <a:headEnd type="none" w="med" len="med"/>
+                      <a:tailEnd type="none" w="med" len="med"/>
+                    </a:lnT>
+                    <a:lnB w="6350" cap="flat" cmpd="sng" algn="ctr">
+                      <a:solidFill>
+                        <a:srgbClr val="C9D1D6"/>
+                      </a:solidFill>
+                      <a:prstDash val="solid"/>
+                      <a:round/>
+                      <a:headEnd type="none" w="med" len="med"/>
+                      <a:tailEnd type="none" w="med" len="med"/>
+                    </a:lnB>
+                    <a:solidFill>
+                      <a:schemeClr val="bg2"/>
+                    </a:solidFill>
+                  </a:tcPr>
+                </a:tc>
+                <a:tc>
+                  <a:txBody>
+                    <a:bodyPr/>
+                    <a:lstStyle/>
+                    <a:p>
+                      <a:pPr indent="0" marL="0">
+                        <a:buNone/>
+                      </a:pPr>
+                      <a:r>
+                        <a:rPr lang="en-US" sz="1300" dirty="0">
+                          <a:solidFill>
+                            <a:schemeClr val="tx1"/>
+                          </a:solidFill>
+                        </a:rPr>
+                        <a:t>Compartidos de proyecto</a:t>
+                      </a:r>
+                      <a:endParaRPr lang="en-US" sz="1300" dirty="0"/>
+                    </a:p>
+                  </a:txBody>
+                  <a:tcPr marL="91440" marR="91440" marT="45720" marB="45720">
+                    <a:lnL w="6350" cap="flat" cmpd="sng" algn="ctr">
+                      <a:solidFill>
+                        <a:srgbClr val="C9D1D6"/>
+                      </a:solidFill>
+                      <a:prstDash val="solid"/>
+                      <a:round/>
+                      <a:headEnd type="none" w="med" len="med"/>
+                      <a:tailEnd type="none" w="med" len="med"/>
+                    </a:lnL>
+                    <a:lnR w="6350" cap="flat" cmpd="sng" algn="ctr">
+                      <a:solidFill>
+                        <a:srgbClr val="C9D1D6"/>
+                      </a:solidFill>
+                      <a:prstDash val="solid"/>
+                      <a:round/>
+                      <a:headEnd type="none" w="med" len="med"/>
+                      <a:tailEnd type="none" w="med" len="med"/>
+                    </a:lnR>
+                    <a:lnT w="6350" cap="flat" cmpd="sng" algn="ctr">
+                      <a:solidFill>
+                        <a:srgbClr val="C9D1D6"/>
+                      </a:solidFill>
+                      <a:prstDash val="solid"/>
+                      <a:round/>
+                      <a:headEnd type="none" w="med" len="med"/>
+                      <a:tailEnd type="none" w="med" len="med"/>
+                    </a:lnT>
+                    <a:lnB w="6350" cap="flat" cmpd="sng" algn="ctr">
+                      <a:solidFill>
+                        <a:srgbClr val="C9D1D6"/>
+                      </a:solidFill>
+                      <a:prstDash val="solid"/>
+                      <a:round/>
+                      <a:headEnd type="none" w="med" len="med"/>
+                      <a:tailEnd type="none" w="med" len="med"/>
+                    </a:lnB>
+                    <a:solidFill>
+                      <a:schemeClr val="bg2"/>
+                    </a:solidFill>
+                  </a:tcPr>
+                </a:tc>
+              </a:tr>
+              <a:tr h="0">
+                <a:tc>
+                  <a:txBody>
+                    <a:bodyPr/>
+                    <a:lstStyle/>
+                    <a:p>
+                      <a:pPr indent="0" marL="0">
+                        <a:buNone/>
+                      </a:pPr>
+                      <a:r>
+                        <a:rPr lang="en-US" sz="1300" dirty="0">
+                          <a:solidFill>
+                            <a:schemeClr val="tx1"/>
+                          </a:solidFill>
+                        </a:rPr>
+                        <a:t>Información de proyecto</a:t>
+                      </a:r>
+                      <a:endParaRPr lang="en-US" sz="1300" dirty="0"/>
+                    </a:p>
+                  </a:txBody>
+                  <a:tcPr marL="91440" marR="91440" marT="45720" marB="45720">
+                    <a:lnL w="6350" cap="flat" cmpd="sng" algn="ctr">
+                      <a:solidFill>
+                        <a:srgbClr val="C9D1D6"/>
+                      </a:solidFill>
+                      <a:prstDash val="solid"/>
+                      <a:round/>
+                      <a:headEnd type="none" w="med" len="med"/>
+                      <a:tailEnd type="none" w="med" len="med"/>
+                    </a:lnL>
+                    <a:lnR w="6350" cap="flat" cmpd="sng" algn="ctr">
+                      <a:solidFill>
+                        <a:srgbClr val="C9D1D6"/>
+                      </a:solidFill>
+                      <a:prstDash val="solid"/>
+                      <a:round/>
+                      <a:headEnd type="none" w="med" len="med"/>
+                      <a:tailEnd type="none" w="med" len="med"/>
+                    </a:lnR>
+                    <a:lnT w="6350" cap="flat" cmpd="sng" algn="ctr">
+                      <a:solidFill>
+                        <a:srgbClr val="C9D1D6"/>
+                      </a:solidFill>
+                      <a:prstDash val="solid"/>
+                      <a:round/>
+                      <a:headEnd type="none" w="med" len="med"/>
+                      <a:tailEnd type="none" w="med" len="med"/>
+                    </a:lnT>
+                    <a:lnB w="6350" cap="flat" cmpd="sng" algn="ctr">
+                      <a:solidFill>
+                        <a:srgbClr val="C9D1D6"/>
+                      </a:solidFill>
+                      <a:prstDash val="solid"/>
+                      <a:round/>
+                      <a:headEnd type="none" w="med" len="med"/>
+                      <a:tailEnd type="none" w="med" len="med"/>
+                    </a:lnB>
+                    <a:solidFill>
+                      <a:schemeClr val="bg1"/>
+                    </a:solidFill>
+                  </a:tcPr>
+                </a:tc>
+                <a:tc>
+                  <a:txBody>
+                    <a:bodyPr/>
+                    <a:lstStyle/>
+                    <a:p>
+                      <a:pPr indent="0" marL="0">
+                        <a:buNone/>
+                      </a:pPr>
+                      <a:r>
+                        <a:rPr lang="en-US" sz="1300" dirty="0">
+                          <a:solidFill>
+                            <a:schemeClr val="tx1"/>
+                          </a:solidFill>
+                        </a:rPr>
+                        <a:t>PAC_Norma_Diseno = NSR-10</a:t>
+                      </a:r>
+                      <a:endParaRPr lang="en-US" sz="1300" dirty="0"/>
+                    </a:p>
+                  </a:txBody>
+                  <a:tcPr marL="91440" marR="91440" marT="45720" marB="45720">
+                    <a:lnL w="6350" cap="flat" cmpd="sng" algn="ctr">
+                      <a:solidFill>
+                        <a:srgbClr val="C9D1D6"/>
+                      </a:solidFill>
+                      <a:prstDash val="solid"/>
+                      <a:round/>
+                      <a:headEnd type="none" w="med" len="med"/>
+                      <a:tailEnd type="none" w="med" len="med"/>
+                    </a:lnL>
+                    <a:lnR w="6350" cap="flat" cmpd="sng" algn="ctr">
+                      <a:solidFill>
+                        <a:srgbClr val="C9D1D6"/>
+                      </a:solidFill>
+                      <a:prstDash val="solid"/>
+                      <a:round/>
+                      <a:headEnd type="none" w="med" len="med"/>
+                      <a:tailEnd type="none" w="med" len="med"/>
+                    </a:lnR>
+                    <a:lnT w="6350" cap="flat" cmpd="sng" algn="ctr">
+                      <a:solidFill>
+                        <a:srgbClr val="C9D1D6"/>
+                      </a:solidFill>
+                      <a:prstDash val="solid"/>
+                      <a:round/>
+                      <a:headEnd type="none" w="med" len="med"/>
+                      <a:tailEnd type="none" w="med" len="med"/>
+                    </a:lnT>
+                    <a:lnB w="6350" cap="flat" cmpd="sng" algn="ctr">
+                      <a:solidFill>
+                        <a:srgbClr val="C9D1D6"/>
+                      </a:solidFill>
+                      <a:prstDash val="solid"/>
+                      <a:round/>
+                      <a:headEnd type="none" w="med" len="med"/>
+                      <a:tailEnd type="none" w="med" len="med"/>
+                    </a:lnB>
+                    <a:solidFill>
+                      <a:schemeClr val="bg1"/>
+                    </a:solidFill>
+                  </a:tcPr>
+                </a:tc>
+                <a:tc>
+                  <a:txBody>
+                    <a:bodyPr/>
+                    <a:lstStyle/>
+                    <a:p>
+                      <a:pPr indent="0" marL="0">
+                        <a:buNone/>
+                      </a:pPr>
+                      <a:r>
+                        <a:rPr lang="en-US" sz="1300" dirty="0">
+                          <a:solidFill>
+                            <a:schemeClr val="tx1"/>
+                          </a:solidFill>
+                        </a:rPr>
+                        <a:t>Compartido de proyecto</a:t>
+                      </a:r>
+                      <a:endParaRPr lang="en-US" sz="1300" dirty="0"/>
+                    </a:p>
+                  </a:txBody>
+                  <a:tcPr marL="91440" marR="91440" marT="45720" marB="45720">
+                    <a:lnL w="6350" cap="flat" cmpd="sng" algn="ctr">
+                      <a:solidFill>
+                        <a:srgbClr val="C9D1D6"/>
+                      </a:solidFill>
+                      <a:prstDash val="solid"/>
+                      <a:round/>
+                      <a:headEnd type="none" w="med" len="med"/>
+                      <a:tailEnd type="none" w="med" len="med"/>
+                    </a:lnL>
+                    <a:lnR w="6350" cap="flat" cmpd="sng" algn="ctr">
+                      <a:solidFill>
+                        <a:srgbClr val="C9D1D6"/>
+                      </a:solidFill>
+                      <a:prstDash val="solid"/>
+                      <a:round/>
+                      <a:headEnd type="none" w="med" len="med"/>
+                      <a:tailEnd type="none" w="med" len="med"/>
+                    </a:lnR>
+                    <a:lnT w="6350" cap="flat" cmpd="sng" algn="ctr">
+                      <a:solidFill>
+                        <a:srgbClr val="C9D1D6"/>
+                      </a:solidFill>
+                      <a:prstDash val="solid"/>
+                      <a:round/>
+                      <a:headEnd type="none" w="med" len="med"/>
+                      <a:tailEnd type="none" w="med" len="med"/>
+                    </a:lnT>
+                    <a:lnB w="6350" cap="flat" cmpd="sng" algn="ctr">
+                      <a:solidFill>
+                        <a:srgbClr val="C9D1D6"/>
+                      </a:solidFill>
+                      <a:prstDash val="solid"/>
+                      <a:round/>
+                      <a:headEnd type="none" w="med" len="med"/>
+                      <a:tailEnd type="none" w="med" len="med"/>
+                    </a:lnB>
+                    <a:solidFill>
+                      <a:schemeClr val="bg1"/>
+                    </a:solidFill>
+                  </a:tcPr>
+                </a:tc>
+              </a:tr>
+              <a:tr h="0">
+                <a:tc>
+                  <a:txBody>
+                    <a:bodyPr/>
+                    <a:lstStyle/>
+                    <a:p>
+                      <a:pPr indent="0" marL="0">
+                        <a:buNone/>
+                      </a:pPr>
+                      <a:r>
+                        <a:rPr lang="en-US" sz="1300" dirty="0">
+                          <a:solidFill>
+                            <a:schemeClr val="tx1"/>
+                          </a:solidFill>
+                        </a:rPr>
+                        <a:t>Familia P89_ZAP</a:t>
+                      </a:r>
+                      <a:endParaRPr lang="en-US" sz="1300" dirty="0"/>
+                    </a:p>
+                  </a:txBody>
+                  <a:tcPr marL="91440" marR="91440" marT="45720" marB="45720">
+                    <a:lnL w="6350" cap="flat" cmpd="sng" algn="ctr">
+                      <a:solidFill>
+                        <a:srgbClr val="C9D1D6"/>
+                      </a:solidFill>
+                      <a:prstDash val="solid"/>
+                      <a:round/>
+                      <a:headEnd type="none" w="med" len="med"/>
+                      <a:tailEnd type="none" w="med" len="med"/>
+                    </a:lnL>
+                    <a:lnR w="6350" cap="flat" cmpd="sng" algn="ctr">
+                      <a:solidFill>
+                        <a:srgbClr val="C9D1D6"/>
+                      </a:solidFill>
+                      <a:prstDash val="solid"/>
+                      <a:round/>
+                      <a:headEnd type="none" w="med" len="med"/>
+                      <a:tailEnd type="none" w="med" len="med"/>
+                    </a:lnR>
+                    <a:lnT w="6350" cap="flat" cmpd="sng" algn="ctr">
+                      <a:solidFill>
+                        <a:srgbClr val="C9D1D6"/>
+                      </a:solidFill>
+                      <a:prstDash val="solid"/>
+                      <a:round/>
+                      <a:headEnd type="none" w="med" len="med"/>
+                      <a:tailEnd type="none" w="med" len="med"/>
+                    </a:lnT>
+                    <a:lnB w="6350" cap="flat" cmpd="sng" algn="ctr">
+                      <a:solidFill>
+                        <a:srgbClr val="C9D1D6"/>
+                      </a:solidFill>
+                      <a:prstDash val="solid"/>
+                      <a:round/>
+                      <a:headEnd type="none" w="med" len="med"/>
+                      <a:tailEnd type="none" w="med" len="med"/>
+                    </a:lnB>
+                    <a:solidFill>
+                      <a:schemeClr val="bg2"/>
+                    </a:solidFill>
+                  </a:tcPr>
+                </a:tc>
+                <a:tc>
+                  <a:txBody>
+                    <a:bodyPr/>
+                    <a:lstStyle/>
+                    <a:p>
+                      <a:pPr indent="0" marL="0">
+                        <a:buNone/>
+                      </a:pPr>
+                      <a:r>
+                        <a:rPr lang="en-US" sz="1300" dirty="0">
+                          <a:solidFill>
+                            <a:schemeClr val="tx1"/>
+                          </a:solidFill>
+                        </a:rPr>
+                        <a:t>ZAP_Lado_B, ZAP_Espesor_h, ZAP_Volumen (fórmula)</a:t>
+                      </a:r>
+                      <a:endParaRPr lang="en-US" sz="1300" dirty="0"/>
+                    </a:p>
+                  </a:txBody>
+                  <a:tcPr marL="91440" marR="91440" marT="45720" marB="45720">
+                    <a:lnL w="6350" cap="flat" cmpd="sng" algn="ctr">
+                      <a:solidFill>
+                        <a:srgbClr val="C9D1D6"/>
+                      </a:solidFill>
+                      <a:prstDash val="solid"/>
+                      <a:round/>
+                      <a:headEnd type="none" w="med" len="med"/>
+                      <a:tailEnd type="none" w="med" len="med"/>
+                    </a:lnL>
+                    <a:lnR w="6350" cap="flat" cmpd="sng" algn="ctr">
+                      <a:solidFill>
+                        <a:srgbClr val="C9D1D6"/>
+                      </a:solidFill>
+                      <a:prstDash val="solid"/>
+                      <a:round/>
+                      <a:headEnd type="none" w="med" len="med"/>
+                      <a:tailEnd type="none" w="med" len="med"/>
+                    </a:lnR>
+                    <a:lnT w="6350" cap="flat" cmpd="sng" algn="ctr">
+                      <a:solidFill>
+                        <a:srgbClr val="C9D1D6"/>
+                      </a:solidFill>
+                      <a:prstDash val="solid"/>
+                      <a:round/>
+                      <a:headEnd type="none" w="med" len="med"/>
+                      <a:tailEnd type="none" w="med" len="med"/>
+                    </a:lnT>
+                    <a:lnB w="6350" cap="flat" cmpd="sng" algn="ctr">
+                      <a:solidFill>
+                        <a:srgbClr val="C9D1D6"/>
+                      </a:solidFill>
+                      <a:prstDash val="solid"/>
+                      <a:round/>
+                      <a:headEnd type="none" w="med" len="med"/>
+                      <a:tailEnd type="none" w="med" len="med"/>
+                    </a:lnB>
+                    <a:solidFill>
+                      <a:schemeClr val="bg2"/>
+                    </a:solidFill>
+                  </a:tcPr>
+                </a:tc>
+                <a:tc>
+                  <a:txBody>
+                    <a:bodyPr/>
+                    <a:lstStyle/>
+                    <a:p>
+                      <a:pPr indent="0" marL="0">
+                        <a:buNone/>
+                      </a:pPr>
+                      <a:r>
+                        <a:rPr lang="en-US" sz="1300" dirty="0">
+                          <a:solidFill>
+                            <a:schemeClr val="tx1"/>
+                          </a:solidFill>
+                        </a:rPr>
+                        <a:t>Compartidos en familia</a:t>
+                      </a:r>
+                      <a:endParaRPr lang="en-US" sz="1300" dirty="0"/>
+                    </a:p>
+                  </a:txBody>
+                  <a:tcPr marL="91440" marR="91440" marT="45720" marB="45720">
+                    <a:lnL w="6350" cap="flat" cmpd="sng" algn="ctr">
+                      <a:solidFill>
+                        <a:srgbClr val="C9D1D6"/>
+                      </a:solidFill>
+                      <a:prstDash val="solid"/>
+                      <a:round/>
+                      <a:headEnd type="none" w="med" len="med"/>
+                      <a:tailEnd type="none" w="med" len="med"/>
+                    </a:lnL>
+                    <a:lnR w="6350" cap="flat" cmpd="sng" algn="ctr">
+                      <a:solidFill>
+                        <a:srgbClr val="C9D1D6"/>
+                      </a:solidFill>
+                      <a:prstDash val="solid"/>
+                      <a:round/>
+                      <a:headEnd type="none" w="med" len="med"/>
+                      <a:tailEnd type="none" w="med" len="med"/>
+                    </a:lnR>
+                    <a:lnT w="6350" cap="flat" cmpd="sng" algn="ctr">
+                      <a:solidFill>
+                        <a:srgbClr val="C9D1D6"/>
+                      </a:solidFill>
+                      <a:prstDash val="solid"/>
+                      <a:round/>
+                      <a:headEnd type="none" w="med" len="med"/>
+                      <a:tailEnd type="none" w="med" len="med"/>
+                    </a:lnT>
+                    <a:lnB w="6350" cap="flat" cmpd="sng" algn="ctr">
+                      <a:solidFill>
+                        <a:srgbClr val="C9D1D6"/>
+                      </a:solidFill>
+                      <a:prstDash val="solid"/>
+                      <a:round/>
+                      <a:headEnd type="none" w="med" len="med"/>
+                      <a:tailEnd type="none" w="med" len="med"/>
+                    </a:lnB>
+                    <a:solidFill>
+                      <a:schemeClr val="bg2"/>
+                    </a:solidFill>
+                  </a:tcPr>
+                </a:tc>
+              </a:tr>
+              <a:tr h="0">
+                <a:tc>
+                  <a:txBody>
+                    <a:bodyPr/>
+                    <a:lstStyle/>
+                    <a:p>
+                      <a:pPr indent="0" marL="0">
+                        <a:buNone/>
+                      </a:pPr>
+                      <a:r>
+                        <a:rPr lang="en-US" sz="1300" dirty="0">
+                          <a:solidFill>
+                            <a:schemeClr val="tx1"/>
+                          </a:solidFill>
+                        </a:rPr>
+                        <a:t>Familia P89_COL</a:t>
+                      </a:r>
+                      <a:endParaRPr lang="en-US" sz="1300" dirty="0"/>
+                    </a:p>
+                  </a:txBody>
+                  <a:tcPr marL="91440" marR="91440" marT="45720" marB="45720">
+                    <a:lnL w="6350" cap="flat" cmpd="sng" algn="ctr">
+                      <a:solidFill>
+                        <a:srgbClr val="C9D1D6"/>
+                      </a:solidFill>
+                      <a:prstDash val="solid"/>
+                      <a:round/>
+                      <a:headEnd type="none" w="med" len="med"/>
+                      <a:tailEnd type="none" w="med" len="med"/>
+                    </a:lnL>
+                    <a:lnR w="6350" cap="flat" cmpd="sng" algn="ctr">
+                      <a:solidFill>
+                        <a:srgbClr val="C9D1D6"/>
+                      </a:solidFill>
+                      <a:prstDash val="solid"/>
+                      <a:round/>
+                      <a:headEnd type="none" w="med" len="med"/>
+                      <a:tailEnd type="none" w="med" len="med"/>
+                    </a:lnR>
+                    <a:lnT w="6350" cap="flat" cmpd="sng" algn="ctr">
+                      <a:solidFill>
+                        <a:srgbClr val="C9D1D6"/>
+                      </a:solidFill>
+                      <a:prstDash val="solid"/>
+                      <a:round/>
+                      <a:headEnd type="none" w="med" len="med"/>
+                      <a:tailEnd type="none" w="med" len="med"/>
+                    </a:lnT>
+                    <a:lnB w="6350" cap="flat" cmpd="sng" algn="ctr">
+                      <a:solidFill>
+                        <a:srgbClr val="C9D1D6"/>
+                      </a:solidFill>
+                      <a:prstDash val="solid"/>
+                      <a:round/>
+                      <a:headEnd type="none" w="med" len="med"/>
+                      <a:tailEnd type="none" w="med" len="med"/>
+                    </a:lnB>
+                    <a:solidFill>
+                      <a:schemeClr val="bg1"/>
+                    </a:solidFill>
+                  </a:tcPr>
+                </a:tc>
+                <a:tc>
+                  <a:txBody>
+                    <a:bodyPr/>
+                    <a:lstStyle/>
+                    <a:p>
+                      <a:pPr indent="0" marL="0">
+                        <a:buNone/>
+                      </a:pPr>
+                      <a:r>
+                        <a:rPr lang="en-US" sz="1300" dirty="0">
+                          <a:solidFill>
+                            <a:schemeClr val="tx1"/>
+                          </a:solidFill>
+                        </a:rPr>
+                        <a:t>COL_Seccion, COL_Altura_Libre (instancia), COL_Refuerzo</a:t>
+                      </a:r>
+                      <a:endParaRPr lang="en-US" sz="1300" dirty="0"/>
+                    </a:p>
+                  </a:txBody>
+                  <a:tcPr marL="91440" marR="91440" marT="45720" marB="45720">
+                    <a:lnL w="6350" cap="flat" cmpd="sng" algn="ctr">
+                      <a:solidFill>
+                        <a:srgbClr val="C9D1D6"/>
+                      </a:solidFill>
+                      <a:prstDash val="solid"/>
+                      <a:round/>
+                      <a:headEnd type="none" w="med" len="med"/>
+                      <a:tailEnd type="none" w="med" len="med"/>
+                    </a:lnL>
+                    <a:lnR w="6350" cap="flat" cmpd="sng" algn="ctr">
+                      <a:solidFill>
+                        <a:srgbClr val="C9D1D6"/>
+                      </a:solidFill>
+                      <a:prstDash val="solid"/>
+                      <a:round/>
+                      <a:headEnd type="none" w="med" len="med"/>
+                      <a:tailEnd type="none" w="med" len="med"/>
+                    </a:lnR>
+                    <a:lnT w="6350" cap="flat" cmpd="sng" algn="ctr">
+                      <a:solidFill>
+                        <a:srgbClr val="C9D1D6"/>
+                      </a:solidFill>
+                      <a:prstDash val="solid"/>
+                      <a:round/>
+                      <a:headEnd type="none" w="med" len="med"/>
+                      <a:tailEnd type="none" w="med" len="med"/>
+                    </a:lnT>
+                    <a:lnB w="6350" cap="flat" cmpd="sng" algn="ctr">
+                      <a:solidFill>
+                        <a:srgbClr val="C9D1D6"/>
+                      </a:solidFill>
+                      <a:prstDash val="solid"/>
+                      <a:round/>
+                      <a:headEnd type="none" w="med" len="med"/>
+                      <a:tailEnd type="none" w="med" len="med"/>
+                    </a:lnB>
+                    <a:solidFill>
+                      <a:schemeClr val="bg1"/>
+                    </a:solidFill>
+                  </a:tcPr>
+                </a:tc>
+                <a:tc>
+                  <a:txBody>
+                    <a:bodyPr/>
+                    <a:lstStyle/>
+                    <a:p>
+                      <a:pPr indent="0" marL="0">
+                        <a:buNone/>
+                      </a:pPr>
+                      <a:r>
+                        <a:rPr lang="en-US" sz="1300" dirty="0">
+                          <a:solidFill>
+                            <a:schemeClr val="tx1"/>
+                          </a:solidFill>
+                        </a:rPr>
+                        <a:t>Compartidos en familia</a:t>
+                      </a:r>
+                      <a:endParaRPr lang="en-US" sz="1300" dirty="0"/>
+                    </a:p>
+                  </a:txBody>
+                  <a:tcPr marL="91440" marR="91440" marT="45720" marB="45720">
+                    <a:lnL w="6350" cap="flat" cmpd="sng" algn="ctr">
+                      <a:solidFill>
+                        <a:srgbClr val="C9D1D6"/>
+                      </a:solidFill>
+                      <a:prstDash val="solid"/>
+                      <a:round/>
+                      <a:headEnd type="none" w="med" len="med"/>
+                      <a:tailEnd type="none" w="med" len="med"/>
+                    </a:lnL>
+                    <a:lnR w="6350" cap="flat" cmpd="sng" algn="ctr">
+                      <a:solidFill>
+                        <a:srgbClr val="C9D1D6"/>
+                      </a:solidFill>
+                      <a:prstDash val="solid"/>
+                      <a:round/>
+                      <a:headEnd type="none" w="med" len="med"/>
+                      <a:tailEnd type="none" w="med" len="med"/>
+                    </a:lnR>
+                    <a:lnT w="6350" cap="flat" cmpd="sng" algn="ctr">
+                      <a:solidFill>
+                        <a:srgbClr val="C9D1D6"/>
+                      </a:solidFill>
+                      <a:prstDash val="solid"/>
+                      <a:round/>
+                      <a:headEnd type="none" w="med" len="med"/>
+                      <a:tailEnd type="none" w="med" len="med"/>
+                    </a:lnT>
+                    <a:lnB w="6350" cap="flat" cmpd="sng" algn="ctr">
+                      <a:solidFill>
+                        <a:srgbClr val="C9D1D6"/>
+                      </a:solidFill>
+                      <a:prstDash val="solid"/>
+                      <a:round/>
+                      <a:headEnd type="none" w="med" len="med"/>
+                      <a:tailEnd type="none" w="med" len="med"/>
+                    </a:lnB>
+                    <a:solidFill>
+                      <a:schemeClr val="bg1"/>
+                    </a:solidFill>
+                  </a:tcPr>
+                </a:tc>
+              </a:tr>
+              <a:tr h="0">
+                <a:tc>
+                  <a:txBody>
+                    <a:bodyPr/>
+                    <a:lstStyle/>
+                    <a:p>
+                      <a:pPr indent="0" marL="0">
+                        <a:buNone/>
+                      </a:pPr>
+                      <a:r>
+                        <a:rPr lang="en-US" sz="1300" dirty="0">
+                          <a:solidFill>
+                            <a:schemeClr val="tx1"/>
+                          </a:solidFill>
+                        </a:rPr>
+                        <a:t>Familias P89_VCI / P89_COR</a:t>
+                      </a:r>
+                      <a:endParaRPr lang="en-US" sz="1300" dirty="0"/>
+                    </a:p>
+                  </a:txBody>
+                  <a:tcPr marL="91440" marR="91440" marT="45720" marB="45720">
+                    <a:lnL w="6350" cap="flat" cmpd="sng" algn="ctr">
+                      <a:solidFill>
+                        <a:srgbClr val="C9D1D6"/>
+                      </a:solidFill>
+                      <a:prstDash val="solid"/>
+                      <a:round/>
+                      <a:headEnd type="none" w="med" len="med"/>
+                      <a:tailEnd type="none" w="med" len="med"/>
+                    </a:lnL>
+                    <a:lnR w="6350" cap="flat" cmpd="sng" algn="ctr">
+                      <a:solidFill>
+                        <a:srgbClr val="C9D1D6"/>
+                      </a:solidFill>
+                      <a:prstDash val="solid"/>
+                      <a:round/>
+                      <a:headEnd type="none" w="med" len="med"/>
+                      <a:tailEnd type="none" w="med" len="med"/>
+                    </a:lnR>
+                    <a:lnT w="6350" cap="flat" cmpd="sng" algn="ctr">
+                      <a:solidFill>
+                        <a:srgbClr val="C9D1D6"/>
+                      </a:solidFill>
+                      <a:prstDash val="solid"/>
+                      <a:round/>
+                      <a:headEnd type="none" w="med" len="med"/>
+                      <a:tailEnd type="none" w="med" len="med"/>
+                    </a:lnT>
+                    <a:lnB w="6350" cap="flat" cmpd="sng" algn="ctr">
+                      <a:solidFill>
+                        <a:srgbClr val="C9D1D6"/>
+                      </a:solidFill>
+                      <a:prstDash val="solid"/>
+                      <a:round/>
+                      <a:headEnd type="none" w="med" len="med"/>
+                      <a:tailEnd type="none" w="med" len="med"/>
+                    </a:lnB>
+                    <a:solidFill>
+                      <a:schemeClr val="bg2"/>
+                    </a:solidFill>
+                  </a:tcPr>
+                </a:tc>
+                <a:tc>
+                  <a:txBody>
+                    <a:bodyPr/>
+                    <a:lstStyle/>
+                    <a:p>
+                      <a:pPr indent="0" marL="0">
+                        <a:buNone/>
+                      </a:pPr>
+                      <a:r>
+                        <a:rPr lang="en-US" sz="1300" dirty="0">
+                          <a:solidFill>
+                            <a:schemeClr val="tx1"/>
+                          </a:solidFill>
+                        </a:rPr>
+                        <a:t>VCI_Seccion, VCI_Eje, VCI_Refuerzo / COR_Perfil, COR_Espesor, COR_Separacion</a:t>
+                      </a:r>
+                      <a:endParaRPr lang="en-US" sz="1300" dirty="0"/>
+                    </a:p>
+                  </a:txBody>
+                  <a:tcPr marL="91440" marR="91440" marT="45720" marB="45720">
+                    <a:lnL w="6350" cap="flat" cmpd="sng" algn="ctr">
+                      <a:solidFill>
+                        <a:srgbClr val="C9D1D6"/>
+                      </a:solidFill>
+                      <a:prstDash val="solid"/>
+                      <a:round/>
+                      <a:headEnd type="none" w="med" len="med"/>
+                      <a:tailEnd type="none" w="med" len="med"/>
+                    </a:lnL>
+                    <a:lnR w="6350" cap="flat" cmpd="sng" algn="ctr">
+                      <a:solidFill>
+                        <a:srgbClr val="C9D1D6"/>
+                      </a:solidFill>
+                      <a:prstDash val="solid"/>
+                      <a:round/>
+                      <a:headEnd type="none" w="med" len="med"/>
+                      <a:tailEnd type="none" w="med" len="med"/>
+                    </a:lnR>
+                    <a:lnT w="6350" cap="flat" cmpd="sng" algn="ctr">
+                      <a:solidFill>
+                        <a:srgbClr val="C9D1D6"/>
+                      </a:solidFill>
+                      <a:prstDash val="solid"/>
+                      <a:round/>
+                      <a:headEnd type="none" w="med" len="med"/>
+                      <a:tailEnd type="none" w="med" len="med"/>
+                    </a:lnT>
+                    <a:lnB w="6350" cap="flat" cmpd="sng" algn="ctr">
+                      <a:solidFill>
+                        <a:srgbClr val="C9D1D6"/>
+                      </a:solidFill>
+                      <a:prstDash val="solid"/>
+                      <a:round/>
+                      <a:headEnd type="none" w="med" len="med"/>
+                      <a:tailEnd type="none" w="med" len="med"/>
+                    </a:lnB>
+                    <a:solidFill>
+                      <a:schemeClr val="bg2"/>
+                    </a:solidFill>
+                  </a:tcPr>
+                </a:tc>
+                <a:tc>
+                  <a:txBody>
+                    <a:bodyPr/>
+                    <a:lstStyle/>
+                    <a:p>
+                      <a:pPr indent="0" marL="0">
+                        <a:buNone/>
+                      </a:pPr>
+                      <a:r>
+                        <a:rPr lang="en-US" sz="1300" dirty="0">
+                          <a:solidFill>
+                            <a:schemeClr val="tx1"/>
+                          </a:solidFill>
+                        </a:rPr>
+                        <a:t>Compartidos en familia</a:t>
+                      </a:r>
+                      <a:endParaRPr lang="en-US" sz="1300" dirty="0"/>
+                    </a:p>
+                  </a:txBody>
+                  <a:tcPr marL="91440" marR="91440" marT="45720" marB="45720">
+                    <a:lnL w="6350" cap="flat" cmpd="sng" algn="ctr">
+                      <a:solidFill>
+                        <a:srgbClr val="C9D1D6"/>
+                      </a:solidFill>
+                      <a:prstDash val="solid"/>
+                      <a:round/>
+                      <a:headEnd type="none" w="med" len="med"/>
+                      <a:tailEnd type="none" w="med" len="med"/>
+                    </a:lnL>
+                    <a:lnR w="6350" cap="flat" cmpd="sng" algn="ctr">
+                      <a:solidFill>
+                        <a:srgbClr val="C9D1D6"/>
+                      </a:solidFill>
+                      <a:prstDash val="solid"/>
+                      <a:round/>
+                      <a:headEnd type="none" w="med" len="med"/>
+                      <a:tailEnd type="none" w="med" len="med"/>
+                    </a:lnR>
+                    <a:lnT w="6350" cap="flat" cmpd="sng" algn="ctr">
+                      <a:solidFill>
+                        <a:srgbClr val="C9D1D6"/>
+                      </a:solidFill>
+                      <a:prstDash val="solid"/>
+                      <a:round/>
+                      <a:headEnd type="none" w="med" len="med"/>
+                      <a:tailEnd type="none" w="med" len="med"/>
+                    </a:lnT>
+                    <a:lnB w="6350" cap="flat" cmpd="sng" algn="ctr">
+                      <a:solidFill>
+                        <a:srgbClr val="C9D1D6"/>
+                      </a:solidFill>
+                      <a:prstDash val="solid"/>
+                      <a:round/>
+                      <a:headEnd type="none" w="med" len="med"/>
+                      <a:tailEnd type="none" w="med" len="med"/>
+                    </a:lnB>
+                    <a:solidFill>
+                      <a:schemeClr val="bg2"/>
+                    </a:solidFill>
+                  </a:tcPr>
+                </a:tc>
+              </a:tr>
+            </a:tbl>
+          </a:graphicData>
+        </a:graphic>
+      </p:graphicFrame>
+      <p:sp>
+        <p:nvSpPr>
+          <p:cNvPr id="9" name="Text 5"/>
+          <p:cNvSpPr txBox="1"/>
+          <p:nvPr/>
+        </p:nvSpPr>
+        <p:spPr>
+          <a:xfrm>
+            <a:off x="3657600" y="4206240"/>
+            <a:ext cx="8001000" cy="914400"/>
+          </a:xfrm>
+          <a:prstGeom prst="rect">
+            <a:avLst/>
+          </a:prstGeom>
+          <a:noFill/>
+          <a:ln/>
+        </p:spPr>
+        <p:txBody>
+          <a:bodyPr wrap="square" rtlCol="0" anchor="t"/>
+          <a:lstStyle/>
+          <a:p>
+            <a:pPr indent="0" marL="0">
               <a:buNone/>
             </a:pPr>
             <a:r>
-              <a:rPr lang="en-US" sz="1300" dirty="0">
+              <a:rPr lang="en-US" sz="1400" b="1" dirty="0">
                 <a:solidFill>
-                  <a:schemeClr val="tx2"/>
+                  <a:schemeClr val="tx1"/>
                 </a:solidFill>
               </a:rPr>
-              <a:t>Gestionar → Parámetros de proyecto (los 5 PAC_)</a:t>
+              <a:t>En la captura: </a:t>
             </a:r>
-            <a:endParaRPr lang="en-US" sz="1300" dirty="0"/>
-          </a:p>
-        </p:txBody>
-      </p:sp>
-      <p:sp>
-        <p:nvSpPr>
-          <p:cNvPr id="7" name="imagen"/>
-          <p:cNvSpPr/>
-          <p:nvPr/>
-        </p:nvSpPr>
-        <p:spPr>
-          <a:xfrm>
-            <a:off x="4315968" y="1417320"/>
-            <a:ext cx="3566160" cy="4023360"/>
-          </a:xfrm>
-          <a:prstGeom prst="roundRect">
-            <a:avLst>
-              <a:gd name="adj" fmla="val 3846"/>
-            </a:avLst>
-          </a:prstGeom>
-          <a:solidFill>
-            <a:schemeClr val="bg2"/>
-          </a:solidFill>
-          <a:ln w="15875">
-            <a:solidFill>
-              <a:schemeClr val="tx2"/>
-            </a:solidFill>
-            <a:prstDash val="dash"/>
-          </a:ln>
-        </p:spPr>
-      </p:sp>
-      <p:sp>
-        <p:nvSpPr>
-          <p:cNvPr id="8" name="Text 6"/>
-          <p:cNvSpPr txBox="1"/>
-          <p:nvPr/>
-        </p:nvSpPr>
-        <p:spPr>
-          <a:xfrm>
-            <a:off x="4498848" y="1417320"/>
-            <a:ext cx="3200400" cy="4023360"/>
-          </a:xfrm>
-          <a:prstGeom prst="rect">
-            <a:avLst/>
-          </a:prstGeom>
-          <a:noFill/>
-          <a:ln/>
-        </p:spPr>
-        <p:txBody>
-          <a:bodyPr wrap="square" rtlCol="0" anchor="ctr"/>
-          <a:lstStyle/>
-          <a:p>
-            <a:pPr algn="ctr" indent="0" marL="0">
-              <a:buNone/>
-            </a:pPr>
-            <a:r>
-              <a:rPr lang="en-US" sz="1300" b="1" dirty="0">
-                <a:solidFill>
-                  <a:schemeClr val="tx2"/>
-                </a:solidFill>
-              </a:rPr>
-              <a:t>INSERTE AQUÍ SU IMAGEN</a:t>
-            </a:r>
-            <a:endParaRPr lang="en-US" sz="1300" dirty="0"/>
-          </a:p>
-          <a:p>
-            <a:pPr algn="ctr" indent="0" marL="0">
-              <a:buNone/>
-            </a:pPr>
-            <a:r>
-              <a:rPr lang="en-US" sz="1300" dirty="0">
-                <a:solidFill>
-                  <a:schemeClr val="tx2"/>
-                </a:solidFill>
-              </a:rPr>
-              <a:t>Propiedades de una columna (COL_Altura_Libre de instancia)</a:t>
-            </a:r>
-            <a:endParaRPr lang="en-US" sz="1300" dirty="0"/>
-          </a:p>
-        </p:txBody>
-      </p:sp>
-      <p:sp>
-        <p:nvSpPr>
-          <p:cNvPr id="9" name="imagen"/>
-          <p:cNvSpPr/>
-          <p:nvPr/>
-        </p:nvSpPr>
-        <p:spPr>
-          <a:xfrm>
-            <a:off x="8083296" y="1417320"/>
-            <a:ext cx="3566160" cy="4023360"/>
-          </a:xfrm>
-          <a:prstGeom prst="roundRect">
-            <a:avLst>
-              <a:gd name="adj" fmla="val 3846"/>
-            </a:avLst>
-          </a:prstGeom>
-          <a:solidFill>
-            <a:schemeClr val="bg2"/>
-          </a:solidFill>
-          <a:ln w="15875">
-            <a:solidFill>
-              <a:schemeClr val="tx2"/>
-            </a:solidFill>
-            <a:prstDash val="dash"/>
-          </a:ln>
-        </p:spPr>
-      </p:sp>
-      <p:sp>
-        <p:nvSpPr>
-          <p:cNvPr id="10" name="Text 8"/>
-          <p:cNvSpPr txBox="1"/>
-          <p:nvPr/>
-        </p:nvSpPr>
-        <p:spPr>
-          <a:xfrm>
-            <a:off x="8266176" y="1417320"/>
-            <a:ext cx="3200400" cy="4023360"/>
-          </a:xfrm>
-          <a:prstGeom prst="rect">
-            <a:avLst/>
-          </a:prstGeom>
-          <a:noFill/>
-          <a:ln/>
-        </p:spPr>
-        <p:txBody>
-          <a:bodyPr wrap="square" rtlCol="0" anchor="ctr"/>
-          <a:lstStyle/>
-          <a:p>
-            <a:pPr algn="ctr" indent="0" marL="0">
-              <a:buNone/>
-            </a:pPr>
-            <a:r>
-              <a:rPr lang="en-US" sz="1300" b="1" dirty="0">
-                <a:solidFill>
-                  <a:schemeClr val="tx2"/>
-                </a:solidFill>
-              </a:rPr>
-              <a:t>INSERTE AQUÍ SU IMAGEN</a:t>
-            </a:r>
-            <a:endParaRPr lang="en-US" sz="1300" dirty="0"/>
-          </a:p>
-          <a:p>
-            <a:pPr algn="ctr" indent="0" marL="0">
-              <a:buNone/>
-            </a:pPr>
-            <a:r>
-              <a:rPr lang="en-US" sz="1300" dirty="0">
-                <a:solidFill>
-                  <a:schemeClr val="tx2"/>
-                </a:solidFill>
-              </a:rPr>
-              <a:t>Propiedades de una correa o de la losa</a:t>
-            </a:r>
-            <a:endParaRPr lang="en-US" sz="1300" dirty="0"/>
-          </a:p>
-        </p:txBody>
-      </p:sp>
-      <p:sp>
-        <p:nvSpPr>
-          <p:cNvPr id="11" name="Text 9"/>
-          <p:cNvSpPr txBox="1"/>
-          <p:nvPr/>
-        </p:nvSpPr>
-        <p:spPr>
-          <a:xfrm>
-            <a:off x="548640" y="5577840"/>
-            <a:ext cx="3566160" cy="548640"/>
-          </a:xfrm>
-          <a:prstGeom prst="rect">
-            <a:avLst/>
-          </a:prstGeom>
-          <a:noFill/>
-          <a:ln/>
-        </p:spPr>
-        <p:txBody>
-          <a:bodyPr wrap="square" rtlCol="0" anchor="ctr"/>
-          <a:lstStyle/>
-          <a:p>
-            <a:pPr algn="ctr" indent="0" marL="0">
+            <a:pPr indent="0" marL="0">
               <a:buNone/>
             </a:pPr>
             <a:r>
@@ -6192,79 +7200,7 @@
                   <a:schemeClr val="tx1"/>
                 </a:solidFill>
               </a:rPr>
-              <a:t>Parámetros comunes vinculados al proyecto</a:t>
-            </a:r>
-            <a:endParaRPr lang="en-US" sz="1400" dirty="0"/>
-          </a:p>
-        </p:txBody>
-      </p:sp>
-      <p:sp>
-        <p:nvSpPr>
-          <p:cNvPr id="12" name="Text 10"/>
-          <p:cNvSpPr txBox="1"/>
-          <p:nvPr/>
-        </p:nvSpPr>
-        <p:spPr>
-          <a:xfrm>
-            <a:off x="4315968" y="5577840"/>
-            <a:ext cx="3566160" cy="548640"/>
-          </a:xfrm>
-          <a:prstGeom prst="rect">
-            <a:avLst/>
-          </a:prstGeom>
-          <a:noFill/>
-          <a:ln/>
-        </p:spPr>
-        <p:txBody>
-          <a:bodyPr wrap="square" rtlCol="0" anchor="ctr"/>
-          <a:lstStyle/>
-          <a:p>
-            <a:pPr algn="ctr" indent="0" marL="0">
-              <a:buNone/>
-            </a:pPr>
-            <a:r>
-              <a:rPr lang="en-US" sz="1400" dirty="0">
-                <a:solidFill>
-                  <a:schemeClr val="tx1"/>
-                </a:solidFill>
-              </a:rPr>
-              <a:t>Instancia: 2,75 m o 5,75 m según el eje</a:t>
-            </a:r>
-            <a:endParaRPr lang="en-US" sz="1400" dirty="0"/>
-          </a:p>
-        </p:txBody>
-      </p:sp>
-      <p:sp>
-        <p:nvSpPr>
-          <p:cNvPr id="13" name="Text 11"/>
-          <p:cNvSpPr txBox="1"/>
-          <p:nvPr/>
-        </p:nvSpPr>
-        <p:spPr>
-          <a:xfrm>
-            <a:off x="8083296" y="5577840"/>
-            <a:ext cx="3566160" cy="548640"/>
-          </a:xfrm>
-          <a:prstGeom prst="rect">
-            <a:avLst/>
-          </a:prstGeom>
-          <a:noFill/>
-          <a:ln/>
-        </p:spPr>
-        <p:txBody>
-          <a:bodyPr wrap="square" rtlCol="0" anchor="ctr"/>
-          <a:lstStyle/>
-          <a:p>
-            <a:pPr algn="ctr" indent="0" marL="0">
-              <a:buNone/>
-            </a:pPr>
-            <a:r>
-              <a:rPr lang="en-US" sz="1400" dirty="0">
-                <a:solidFill>
-                  <a:schemeClr val="tx1"/>
-                </a:solidFill>
-              </a:rPr>
-              <a:t>Material de color por objeto</a:t>
+              <a:t>PAC_Nivel_Referencia = N+0,00 (común, instancia), Material estructural = P89 Concreto - Columnas (color azul) y COL_Altura_Libre = 2,75 m (particular, instancia).</a:t>
             </a:r>
             <a:endParaRPr lang="en-US" sz="1400" dirty="0"/>
           </a:p>

</xml_diff>